<commit_message>
Ajout explicatif code php les tableaux
</commit_message>
<xml_diff>
--- a/PHP/Cours_3_Tableaux/Le_PHP_3_tableaux.pptx
+++ b/PHP/Cours_3_Tableaux/Le_PHP_3_tableaux.pptx
@@ -314,7 +314,7 @@
             <a:fld id="{B61BEF0D-F0BB-DE4B-95CE-6DB70DBA9567}" type="datetimeFigureOut">
               <a:rPr lang="en-US" dirty="0"/>
               <a:pPr/>
-              <a:t>2/5/2025</a:t>
+              <a:t>2/6/2025</a:t>
             </a:fld>
             <a:endParaRPr lang="en-US" dirty="0"/>
           </a:p>
@@ -747,7 +747,7 @@
             <a:fld id="{B61BEF0D-F0BB-DE4B-95CE-6DB70DBA9567}" type="datetimeFigureOut">
               <a:rPr lang="en-US" dirty="0"/>
               <a:pPr/>
-              <a:t>2/5/2025</a:t>
+              <a:t>2/6/2025</a:t>
             </a:fld>
             <a:endParaRPr lang="en-US" dirty="0"/>
           </a:p>
@@ -994,7 +994,7 @@
             <a:fld id="{B61BEF0D-F0BB-DE4B-95CE-6DB70DBA9567}" type="datetimeFigureOut">
               <a:rPr lang="en-US" dirty="0"/>
               <a:pPr/>
-              <a:t>2/5/2025</a:t>
+              <a:t>2/6/2025</a:t>
             </a:fld>
             <a:endParaRPr lang="en-US" dirty="0"/>
           </a:p>
@@ -1299,7 +1299,7 @@
             <a:fld id="{B61BEF0D-F0BB-DE4B-95CE-6DB70DBA9567}" type="datetimeFigureOut">
               <a:rPr lang="en-US" dirty="0"/>
               <a:pPr/>
-              <a:t>2/5/2025</a:t>
+              <a:t>2/6/2025</a:t>
             </a:fld>
             <a:endParaRPr lang="en-US" dirty="0"/>
           </a:p>
@@ -1614,7 +1614,7 @@
             <a:fld id="{B61BEF0D-F0BB-DE4B-95CE-6DB70DBA9567}" type="datetimeFigureOut">
               <a:rPr lang="en-US" dirty="0"/>
               <a:pPr/>
-              <a:t>2/5/2025</a:t>
+              <a:t>2/6/2025</a:t>
             </a:fld>
             <a:endParaRPr lang="en-US" dirty="0"/>
           </a:p>
@@ -1913,7 +1913,7 @@
             <a:fld id="{B61BEF0D-F0BB-DE4B-95CE-6DB70DBA9567}" type="datetimeFigureOut">
               <a:rPr lang="en-US" dirty="0"/>
               <a:pPr/>
-              <a:t>2/5/2025</a:t>
+              <a:t>2/6/2025</a:t>
             </a:fld>
             <a:endParaRPr lang="en-US" dirty="0"/>
           </a:p>
@@ -2277,7 +2277,7 @@
             <a:fld id="{B61BEF0D-F0BB-DE4B-95CE-6DB70DBA9567}" type="datetimeFigureOut">
               <a:rPr lang="en-US" dirty="0"/>
               <a:pPr/>
-              <a:t>2/5/2025</a:t>
+              <a:t>2/6/2025</a:t>
             </a:fld>
             <a:endParaRPr lang="en-US" dirty="0"/>
           </a:p>
@@ -2448,7 +2448,7 @@
             <a:fld id="{B61BEF0D-F0BB-DE4B-95CE-6DB70DBA9567}" type="datetimeFigureOut">
               <a:rPr lang="en-US" dirty="0"/>
               <a:pPr/>
-              <a:t>2/5/2025</a:t>
+              <a:t>2/6/2025</a:t>
             </a:fld>
             <a:endParaRPr lang="en-US" dirty="0"/>
           </a:p>
@@ -2625,7 +2625,7 @@
             <a:fld id="{B61BEF0D-F0BB-DE4B-95CE-6DB70DBA9567}" type="datetimeFigureOut">
               <a:rPr lang="en-US" dirty="0"/>
               <a:pPr/>
-              <a:t>2/5/2025</a:t>
+              <a:t>2/6/2025</a:t>
             </a:fld>
             <a:endParaRPr lang="en-US" dirty="0"/>
           </a:p>
@@ -2792,7 +2792,7 @@
             <a:fld id="{B61BEF0D-F0BB-DE4B-95CE-6DB70DBA9567}" type="datetimeFigureOut">
               <a:rPr lang="en-US" dirty="0"/>
               <a:pPr/>
-              <a:t>2/5/2025</a:t>
+              <a:t>2/6/2025</a:t>
             </a:fld>
             <a:endParaRPr lang="en-US" dirty="0"/>
           </a:p>
@@ -3039,7 +3039,7 @@
             <a:fld id="{B61BEF0D-F0BB-DE4B-95CE-6DB70DBA9567}" type="datetimeFigureOut">
               <a:rPr lang="en-US" dirty="0"/>
               <a:pPr/>
-              <a:t>2/5/2025</a:t>
+              <a:t>2/6/2025</a:t>
             </a:fld>
             <a:endParaRPr lang="en-US" dirty="0"/>
           </a:p>
@@ -3272,7 +3272,7 @@
             <a:fld id="{B61BEF0D-F0BB-DE4B-95CE-6DB70DBA9567}" type="datetimeFigureOut">
               <a:rPr lang="en-US" dirty="0"/>
               <a:pPr/>
-              <a:t>2/5/2025</a:t>
+              <a:t>2/6/2025</a:t>
             </a:fld>
             <a:endParaRPr lang="en-US" dirty="0"/>
           </a:p>
@@ -3651,7 +3651,7 @@
             <a:fld id="{B61BEF0D-F0BB-DE4B-95CE-6DB70DBA9567}" type="datetimeFigureOut">
               <a:rPr lang="en-US" dirty="0"/>
               <a:pPr/>
-              <a:t>2/5/2025</a:t>
+              <a:t>2/6/2025</a:t>
             </a:fld>
             <a:endParaRPr lang="en-US" dirty="0"/>
           </a:p>
@@ -3766,7 +3766,7 @@
             <a:fld id="{B61BEF0D-F0BB-DE4B-95CE-6DB70DBA9567}" type="datetimeFigureOut">
               <a:rPr lang="en-US" dirty="0"/>
               <a:pPr/>
-              <a:t>2/5/2025</a:t>
+              <a:t>2/6/2025</a:t>
             </a:fld>
             <a:endParaRPr lang="en-US" dirty="0"/>
           </a:p>
@@ -3858,7 +3858,7 @@
             <a:fld id="{B61BEF0D-F0BB-DE4B-95CE-6DB70DBA9567}" type="datetimeFigureOut">
               <a:rPr lang="en-US" dirty="0"/>
               <a:pPr/>
-              <a:t>2/5/2025</a:t>
+              <a:t>2/6/2025</a:t>
             </a:fld>
             <a:endParaRPr lang="en-US" dirty="0"/>
           </a:p>
@@ -4110,7 +4110,7 @@
             <a:fld id="{B61BEF0D-F0BB-DE4B-95CE-6DB70DBA9567}" type="datetimeFigureOut">
               <a:rPr lang="en-US" dirty="0"/>
               <a:pPr/>
-              <a:t>2/5/2025</a:t>
+              <a:t>2/6/2025</a:t>
             </a:fld>
             <a:endParaRPr lang="en-US" dirty="0"/>
           </a:p>
@@ -4390,7 +4390,7 @@
             <a:fld id="{B61BEF0D-F0BB-DE4B-95CE-6DB70DBA9567}" type="datetimeFigureOut">
               <a:rPr lang="en-US" dirty="0"/>
               <a:pPr/>
-              <a:t>2/5/2025</a:t>
+              <a:t>2/6/2025</a:t>
             </a:fld>
             <a:endParaRPr lang="en-US" dirty="0"/>
           </a:p>
@@ -4793,7 +4793,7 @@
             <a:fld id="{B61BEF0D-F0BB-DE4B-95CE-6DB70DBA9567}" type="datetimeFigureOut">
               <a:rPr lang="en-US" dirty="0"/>
               <a:pPr/>
-              <a:t>2/5/2025</a:t>
+              <a:t>2/6/2025</a:t>
             </a:fld>
             <a:endParaRPr lang="en-US" dirty="0"/>
           </a:p>
@@ -5834,7 +5834,7 @@
             </a:r>
             <a:r>
               <a:rPr lang="fr-FR" sz="2000" dirty="0"/>
-              <a:t> est spécialement conçue pour parcourir facilement les tableaux en PHP. Elle permet de récupérer directement les valeurs d’un tableau avoir à gérer les indices manuellement (sans variable $i pour allez chercher la position par exemple) </a:t>
+              <a:t> est spécialement conçue pour parcourir facilement les tableaux en PHP. Elle permet de récupérer directement les valeurs d’un tableau sans avoir à gérer les indices manuellement (sans variable $i pour allez chercher la position par exemple) </a:t>
             </a:r>
           </a:p>
           <a:p>
@@ -9754,7 +9754,7 @@
             </a:pPr>
             <a:r>
               <a:rPr lang="fr-FR" dirty="0"/>
-              <a:t>Parcourir un tableau permet d’accéder à des éléments sans connaître à l’avance sa taille ou son contenu. Cela et particulièrement utile lorsque l’ont travaille avec des listes de données</a:t>
+              <a:t>Parcourir un tableau permet d’accéder à des éléments sans connaître à l’avance sa taille ou son contenu. Cela est particulièrement utile lorsque l’ont travaille avec des listes de données</a:t>
             </a:r>
           </a:p>
           <a:p>
@@ -10252,7 +10252,7 @@
             </a:r>
             <a:r>
               <a:rPr lang="fr-FR" sz="2000" dirty="0"/>
-              <a:t> est une structure de contrôle qui permet d’exécuter un bloc de code un certain nombre de fois. Elle est utile pour parcourir les tableaux indexés où l’ont accès aux éléments grâce à leur indices.</a:t>
+              <a:t> est une structure de contrôle qui permet d’exécuter un bloc de code un certain nombre de fois. Elle est utile pour parcourir les tableaux indexés où l’ont accède aux éléments grâce à leur indices.</a:t>
             </a:r>
           </a:p>
           <a:p>

</xml_diff>